<commit_message>
Fix ascending/descending sort order and dynamic legend positioning
- Fix inverted sort order logic in template_builder.py (was setting opposite of selected)
- Add dynamic legend positioning based on sort order:
  - Ascending: legend at top of chart
  - Descending: legend at bottom of chart
- Update both preview (template_builder.py) and report rendering (main_window.py)
</commit_message>
<xml_diff>
--- a/output/Report_20251216.pptx
+++ b/output/Report_20251216.pptx
@@ -5148,7 +5148,7 @@
       </p:sp>
       <p:pic>
         <p:nvPicPr>
-          <p:cNvPr id="4" name="Picture 3" descr="tmp0id_5r3e.png"/>
+          <p:cNvPr id="4" name="Picture 3" descr="tmpcs2al72_.png"/>
           <p:cNvPicPr>
             <a:picLocks noChangeAspect="1"/>
           </p:cNvPicPr>
@@ -5242,7 +5242,7 @@
       </p:sp>
       <p:pic>
         <p:nvPicPr>
-          <p:cNvPr id="4" name="Picture 3" descr="tmpzygvb0tq.png"/>
+          <p:cNvPr id="4" name="Picture 3" descr="tmpf7na_fth.png"/>
           <p:cNvPicPr>
             <a:picLocks noChangeAspect="1"/>
           </p:cNvPicPr>
@@ -5336,7 +5336,7 @@
       </p:sp>
       <p:pic>
         <p:nvPicPr>
-          <p:cNvPr id="4" name="Picture 3" descr="tmpsuidqh14.png"/>
+          <p:cNvPr id="4" name="Picture 3" descr="tmpj_rb2vmq.png"/>
           <p:cNvPicPr>
             <a:picLocks noChangeAspect="1"/>
           </p:cNvPicPr>
@@ -5395,7 +5395,7 @@
       </p:sp>
       <p:pic>
         <p:nvPicPr>
-          <p:cNvPr id="3" name="Picture 2" descr="tmp2jtt_j_s.png"/>
+          <p:cNvPr id="3" name="Picture 2" descr="tmpgj9fu6bj.png"/>
           <p:cNvPicPr>
             <a:picLocks noChangeAspect="1"/>
           </p:cNvPicPr>
@@ -5489,7 +5489,7 @@
       </p:sp>
       <p:pic>
         <p:nvPicPr>
-          <p:cNvPr id="4" name="Picture 3" descr="tmpe4x0cz0d.png"/>
+          <p:cNvPr id="4" name="Picture 3" descr="tmp5xul2c3j.png"/>
           <p:cNvPicPr>
             <a:picLocks noChangeAspect="1"/>
           </p:cNvPicPr>

</xml_diff>